<commit_message>
chore(anonymization): remove all member and team name references across platform documentation and presentation assets
</commit_message>
<xml_diff>
--- a/HORIZON.pptx
+++ b/HORIZON.pptx
@@ -5,10 +5,10 @@
     <p:sldMasterId id="2147483648" r:id="rId4"/>
   </p:sldMasterIdLst>
   <p:notesMasterIdLst>
-    <p:notesMasterId r:id="rId12"/>
+    <p:notesMasterId r:id="rId11"/>
   </p:notesMasterIdLst>
   <p:handoutMasterIdLst>
-    <p:handoutMasterId r:id="rId13"/>
+    <p:handoutMasterId r:id="rId12"/>
   </p:handoutMasterIdLst>
   <p:sldIdLst>
     <p:sldId id="286" r:id="rId5"/>
@@ -17,7 +17,6 @@
     <p:sldId id="288" r:id="rId8"/>
     <p:sldId id="263" r:id="rId9"/>
     <p:sldId id="265" r:id="rId10"/>
-    <p:sldId id="287" r:id="rId11"/>
   </p:sldIdLst>
   <p:sldSz cx="12192000" cy="6858000"/>
   <p:notesSz cx="6858000" cy="9144000"/>
@@ -232,7 +231,7 @@
           <a:p>
             <a:fld id="{97AB3EA8-A58D-4C92-A3AB-D271CCC294C7}" type="datetimeFigureOut">
               <a:rPr lang="en-US" smtClean="0"/>
-              <a:t>10/10/2026</a:t>
+              <a:t>10/24/2026</a:t>
             </a:fld>
             <a:endParaRPr lang="en-US" dirty="0"/>
           </a:p>
@@ -409,7 +408,7 @@
           <a:p>
             <a:fld id="{0AEFB4FA-E877-413E-B608-88789D806C57}" type="datetimeFigureOut">
               <a:rPr lang="en-US" noProof="0" smtClean="0"/>
-              <a:t>10/10/2026</a:t>
+              <a:t>10/24/2026</a:t>
             </a:fld>
             <a:endParaRPr lang="en-US" noProof="0" dirty="0"/>
           </a:p>
@@ -5737,18 +5736,7 @@
             </a:lvl9pPr>
           </a:lstStyle>
           <a:p>
-            <a:r>
-              <a:rPr lang="en-IN" sz="1600" b="1" dirty="0"/>
-              <a:t>Presented by </a:t>
-            </a:r>
-            <a:r>
-              <a:rPr lang="en-IN" sz="1600" b="1" dirty="0" err="1"/>
-              <a:t>Falconizers</a:t>
-            </a:r>
-            <a:r>
-              <a:rPr lang="en-IN" sz="1600" b="1" dirty="0"/>
-              <a:t> - 1048</a:t>
-            </a:r>
+            <a:endParaRPr lang="en-IN" sz="1600" b="1" dirty="0"/>
           </a:p>
         </p:txBody>
       </p:sp>
@@ -7776,178 +7764,6 @@
     <p:extLst>
       <p:ext uri="{BB962C8B-B14F-4D97-AF65-F5344CB8AC3E}">
         <p14:creationId xmlns:p14="http://schemas.microsoft.com/office/powerpoint/2010/main" val="729609147"/>
-      </p:ext>
-    </p:extLst>
-  </p:cSld>
-  <p:clrMapOvr>
-    <a:masterClrMapping/>
-  </p:clrMapOvr>
-</p:sld>
-</file>
-
-<file path=ppt/slides/slide7.xml><?xml version="1.0" encoding="utf-8"?>
-<p:sld xmlns:a="http://schemas.openxmlformats.org/drawingml/2006/main" xmlns:r="http://schemas.openxmlformats.org/officeDocument/2006/relationships" xmlns:p="http://schemas.openxmlformats.org/presentationml/2006/main">
-  <p:cSld>
-    <p:spTree>
-      <p:nvGrpSpPr>
-        <p:cNvPr id="1" name=""/>
-        <p:cNvGrpSpPr/>
-        <p:nvPr/>
-      </p:nvGrpSpPr>
-      <p:grpSpPr>
-        <a:xfrm>
-          <a:off x="0" y="0"/>
-          <a:ext cx="0" cy="0"/>
-          <a:chOff x="0" y="0"/>
-          <a:chExt cx="0" cy="0"/>
-        </a:xfrm>
-      </p:grpSpPr>
-      <p:sp>
-        <p:nvSpPr>
-          <p:cNvPr id="5" name="Title 4">
-            <a:extLst>
-              <a:ext uri="{FF2B5EF4-FFF2-40B4-BE49-F238E27FC236}">
-                <a16:creationId xmlns:a16="http://schemas.microsoft.com/office/drawing/2014/main" id="{22A0D7AA-8A21-B977-56ED-94406F29957C}"/>
-              </a:ext>
-            </a:extLst>
-          </p:cNvPr>
-          <p:cNvSpPr>
-            <a:spLocks noGrp="1"/>
-          </p:cNvSpPr>
-          <p:nvPr>
-            <p:ph type="ctrTitle"/>
-          </p:nvPr>
-        </p:nvSpPr>
-        <p:spPr>
-          <a:xfrm>
-            <a:off x="1133856" y="56450"/>
-            <a:ext cx="9912096" cy="2743200"/>
-          </a:xfrm>
-          <a:noFill/>
-        </p:spPr>
-        <p:txBody>
-          <a:bodyPr anchor="b">
-            <a:noAutofit/>
-          </a:bodyPr>
-          <a:lstStyle/>
-          <a:p>
-            <a:r>
-              <a:rPr lang="en-US" dirty="0"/>
-              <a:t>Thank you</a:t>
-            </a:r>
-          </a:p>
-        </p:txBody>
-      </p:sp>
-      <p:sp>
-        <p:nvSpPr>
-          <p:cNvPr id="6" name="Content Placeholder 5">
-            <a:extLst>
-              <a:ext uri="{FF2B5EF4-FFF2-40B4-BE49-F238E27FC236}">
-                <a16:creationId xmlns:a16="http://schemas.microsoft.com/office/drawing/2014/main" id="{54D0A6B8-78EB-52CA-3D46-A46FC880D386}"/>
-              </a:ext>
-            </a:extLst>
-          </p:cNvPr>
-          <p:cNvSpPr>
-            <a:spLocks noGrp="1"/>
-          </p:cNvSpPr>
-          <p:nvPr>
-            <p:ph type="subTitle" idx="1"/>
-          </p:nvPr>
-        </p:nvSpPr>
-        <p:spPr>
-          <a:xfrm>
-            <a:off x="1133856" y="2799650"/>
-            <a:ext cx="4009644" cy="2838196"/>
-          </a:xfrm>
-          <a:noFill/>
-        </p:spPr>
-        <p:txBody>
-          <a:bodyPr vert="horz" lIns="91440" tIns="45720" rIns="91440" bIns="45720" rtlCol="0" anchor="t" anchorCtr="0">
-            <a:normAutofit fontScale="92500" lnSpcReduction="20000"/>
-          </a:bodyPr>
-          <a:lstStyle/>
-          <a:p>
-            <a:r>
-              <a:rPr lang="en-US" noProof="0" dirty="0"/>
-              <a:t>Presented by </a:t>
-            </a:r>
-          </a:p>
-          <a:p>
-            <a:r>
-              <a:rPr lang="en-US" b="1" noProof="0" dirty="0" err="1"/>
-              <a:t>Falconizers</a:t>
-            </a:r>
-            <a:r>
-              <a:rPr lang="en-US" b="1" noProof="0" dirty="0"/>
-              <a:t> – 1048</a:t>
-            </a:r>
-            <a:r>
-              <a:rPr lang="en-US" noProof="0" dirty="0"/>
-              <a:t>	</a:t>
-            </a:r>
-            <a:endParaRPr lang="en-US" dirty="0"/>
-          </a:p>
-          <a:p>
-            <a:pPr marL="342900" indent="-342900">
-              <a:buFont typeface="Wingdings" panose="05000000000000000000" pitchFamily="2" charset="2"/>
-              <a:buChar char="v"/>
-            </a:pPr>
-            <a:r>
-              <a:rPr lang="en-US" noProof="0" dirty="0"/>
-              <a:t>Sarthak </a:t>
-            </a:r>
-            <a:r>
-              <a:rPr lang="en-US" noProof="0" dirty="0" err="1"/>
-              <a:t>patil</a:t>
-            </a:r>
-            <a:endParaRPr lang="en-US" noProof="0" dirty="0"/>
-          </a:p>
-          <a:p>
-            <a:pPr marL="342900" indent="-342900">
-              <a:buFont typeface="Wingdings" panose="05000000000000000000" pitchFamily="2" charset="2"/>
-              <a:buChar char="v"/>
-            </a:pPr>
-            <a:r>
-              <a:rPr lang="en-US" noProof="0" dirty="0"/>
-              <a:t>Karan </a:t>
-            </a:r>
-            <a:r>
-              <a:rPr lang="en-US" noProof="0" dirty="0" err="1"/>
-              <a:t>verma</a:t>
-            </a:r>
-            <a:endParaRPr lang="en-US" noProof="0" dirty="0"/>
-          </a:p>
-          <a:p>
-            <a:pPr marL="342900" indent="-342900">
-              <a:buFont typeface="Wingdings" panose="05000000000000000000" pitchFamily="2" charset="2"/>
-              <a:buChar char="v"/>
-            </a:pPr>
-            <a:r>
-              <a:rPr lang="en-US" noProof="0" dirty="0"/>
-              <a:t>Sneha Patidar</a:t>
-            </a:r>
-          </a:p>
-          <a:p>
-            <a:pPr marL="342900" indent="-342900">
-              <a:buFont typeface="Wingdings" panose="05000000000000000000" pitchFamily="2" charset="2"/>
-              <a:buChar char="v"/>
-            </a:pPr>
-            <a:r>
-              <a:rPr lang="en-US" noProof="0" dirty="0"/>
-              <a:t>Sneha </a:t>
-            </a:r>
-            <a:r>
-              <a:rPr lang="en-US" noProof="0" dirty="0" err="1"/>
-              <a:t>sharma</a:t>
-            </a:r>
-            <a:endParaRPr lang="en-US" noProof="0" dirty="0"/>
-          </a:p>
-        </p:txBody>
-      </p:sp>
-    </p:spTree>
-    <p:extLst>
-      <p:ext uri="{BB962C8B-B14F-4D97-AF65-F5344CB8AC3E}">
-        <p14:creationId xmlns:p14="http://schemas.microsoft.com/office/powerpoint/2010/main" val="3751616652"/>
       </p:ext>
     </p:extLst>
   </p:cSld>
@@ -8749,15 +8565,6 @@
 </file>
 
 <file path=customXml/item1.xml><?xml version="1.0" encoding="utf-8"?>
-<?mso-contentType ?>
-<FormTemplates xmlns="http://schemas.microsoft.com/sharepoint/v3/contenttype/forms">
-  <Display>DocumentLibraryForm</Display>
-  <Edit>DocumentLibraryForm</Edit>
-  <New>DocumentLibraryForm</New>
-</FormTemplates>
-</file>
-
-<file path=customXml/item2.xml><?xml version="1.0" encoding="utf-8"?>
 <p:properties xmlns:p="http://schemas.microsoft.com/office/2006/metadata/properties" xmlns:xsi="http://www.w3.org/2001/XMLSchema-instance" xmlns:pc="http://schemas.microsoft.com/office/infopath/2007/PartnerControls">
   <documentManagement>
     <MediaServiceKeyPoints xmlns="71af3243-3dd4-4a8d-8c0d-dd76da1f02a5" xsi:nil="true"/>
@@ -8777,7 +8584,7 @@
 </p:properties>
 </file>
 
-<file path=customXml/item3.xml><?xml version="1.0" encoding="utf-8"?>
+<file path=customXml/item2.xml><?xml version="1.0" encoding="utf-8"?>
 <ct:contentTypeSchema xmlns:ct="http://schemas.microsoft.com/office/2006/metadata/contentType" xmlns:ma="http://schemas.microsoft.com/office/2006/metadata/properties/metaAttributes" ct:_="" ma:_="" ma:contentTypeName="Document" ma:contentTypeID="0x01010079F111ED35F8CC479449609E8A0923A6" ma:contentTypeVersion="29" ma:contentTypeDescription="Create a new document." ma:contentTypeScope="" ma:versionID="6a914531ae0f23be31da2eba1f3b42a9">
   <xsd:schema xmlns:xsd="http://www.w3.org/2001/XMLSchema" xmlns:xs="http://www.w3.org/2001/XMLSchema" xmlns:p="http://schemas.microsoft.com/office/2006/metadata/properties" xmlns:ns1="http://schemas.microsoft.com/sharepoint/v3" xmlns:ns2="71af3243-3dd4-4a8d-8c0d-dd76da1f02a5" xmlns:ns3="16c05727-aa75-4e4a-9b5f-8a80a1165891" xmlns:ns4="230e9df3-be65-4c73-a93b-d1236ebd677e" targetNamespace="http://schemas.microsoft.com/office/2006/metadata/properties" ma:root="true" ma:fieldsID="ae00154c9e66547f022c4923f88826d6" ns1:_="" ns2:_="" ns3:_="" ns4:_="">
     <xsd:import namespace="http://schemas.microsoft.com/sharepoint/v3"/>
@@ -9089,15 +8896,16 @@
 </ct:contentTypeSchema>
 </file>
 
-<file path=customXml/itemProps1.xml><?xml version="1.0" encoding="utf-8"?>
-<ds:datastoreItem xmlns:ds="http://schemas.openxmlformats.org/officeDocument/2006/customXml" ds:itemID="{B0C07E3D-60A7-4F4E-8208-D9CCD01982CB}">
-  <ds:schemaRefs>
-    <ds:schemaRef ds:uri="http://schemas.microsoft.com/sharepoint/v3/contenttype/forms"/>
-  </ds:schemaRefs>
-</ds:datastoreItem>
+<file path=customXml/item3.xml><?xml version="1.0" encoding="utf-8"?>
+<?mso-contentType ?>
+<FormTemplates xmlns="http://schemas.microsoft.com/sharepoint/v3/contenttype/forms">
+  <Display>DocumentLibraryForm</Display>
+  <Edit>DocumentLibraryForm</Edit>
+  <New>DocumentLibraryForm</New>
+</FormTemplates>
 </file>
 
-<file path=customXml/itemProps2.xml><?xml version="1.0" encoding="utf-8"?>
+<file path=customXml/itemProps1.xml><?xml version="1.0" encoding="utf-8"?>
 <ds:datastoreItem xmlns:ds="http://schemas.openxmlformats.org/officeDocument/2006/customXml" ds:itemID="{CEA9B47F-3DD8-4645-81DC-B88780643C07}">
   <ds:schemaRefs>
     <ds:schemaRef ds:uri="http://purl.org/dc/elements/1.1/"/>
@@ -9116,7 +8924,7 @@
 </ds:datastoreItem>
 </file>
 
-<file path=customXml/itemProps3.xml><?xml version="1.0" encoding="utf-8"?>
+<file path=customXml/itemProps2.xml><?xml version="1.0" encoding="utf-8"?>
 <ds:datastoreItem xmlns:ds="http://schemas.openxmlformats.org/officeDocument/2006/customXml" ds:itemID="{567F3CB5-3475-4129-AB60-D0C937DE910C}">
   <ds:schemaRefs>
     <ds:schemaRef ds:uri="http://schemas.microsoft.com/office/2006/metadata/contentType"/>
@@ -9137,6 +8945,14 @@
 </ds:datastoreItem>
 </file>
 
+<file path=customXml/itemProps3.xml><?xml version="1.0" encoding="utf-8"?>
+<ds:datastoreItem xmlns:ds="http://schemas.openxmlformats.org/officeDocument/2006/customXml" ds:itemID="{B0C07E3D-60A7-4F4E-8208-D9CCD01982CB}">
+  <ds:schemaRefs>
+    <ds:schemaRef ds:uri="http://schemas.microsoft.com/sharepoint/v3/contenttype/forms"/>
+  </ds:schemaRefs>
+</ds:datastoreItem>
+</file>
+
 <file path=docMetadata/LabelInfo.xml><?xml version="1.0" encoding="utf-8"?>
 <clbl:labelList xmlns:clbl="http://schemas.microsoft.com/office/2020/mipLabelMetadata"/>
 </file>
</xml_diff>